<commit_message>
feat(corpus): revamp PedalWorks kb-test into a 3-tier hierarchical corpus
Rewrites the synthetic PedalWorks corpus so extraction yields a clean, tiered knowledge graph (Tier 0 super-themes -> Tier 1 sub-nodes -> Tier 2 detail):
- item-first supplier names (Frames Ltd, Wheels Co, ...); dropped generic 'Bicycle'; Scheduler -> Planner
- new docs: architecture-flow, data-model, bom, production, fulfillment, planning_and_demand
- prose<->code twin kept; binaries regenerated with image/table probes preserved
- dropped Dockerfile/Makefile (were ingested as infra noise)

Co-Authored-By: Claude Opus 4.8 (1M context) <noreply@anthropic.com>
</commit_message>
<xml_diff>
--- a/docs/factory_overview.pptx
+++ b/docs/factory_overview.pptx
@@ -3188,7 +3188,7 @@
           <a:lstStyle/>
           <a:p>
             <a:r>
-              <a:t>Scheduler -- fan-out hub: reads PartsDB + OrderDB, triggers Procurement, releases Assembly work</a:t>
+              <a:t>Planner -- fan-out hub: reads OrderDB + PartsDB, triggers Procurement, releases Assembly work</a:t>
             </a:r>
           </a:p>
           <a:p>
@@ -3302,7 +3302,7 @@
           <a:lstStyle/>
           <a:p>
             <a:r>
-              <a:t>Supplier Lead Times</a:t>
+              <a:t>Facility Capacity</a:t>
             </a:r>
           </a:p>
         </p:txBody>
@@ -3317,7 +3317,7 @@
         </p:nvGraphicFramePr>
         <p:xfrm>
           <a:off x="457200" y="1371600"/>
-          <a:ext cx="8229600" cy="2743200"/>
+          <a:ext cx="8229600" cy="1828800"/>
         </p:xfrm>
         <a:graphic>
           <a:graphicData uri="http://schemas.openxmlformats.org/drawingml/2006/table">
@@ -3326,18 +3326,19 @@
                 <a:tableStyleId>{5C22544A-7EE6-4342-B048-85BDC9FD1C3A}</a:tableStyleId>
               </a:tblPr>
               <a:tblGrid>
-                <a:gridCol w="2743200"/>
-                <a:gridCol w="2743200"/>
-                <a:gridCol w="2743200"/>
+                <a:gridCol w="2057400"/>
+                <a:gridCol w="2057400"/>
+                <a:gridCol w="2057400"/>
+                <a:gridCol w="2057400"/>
               </a:tblGrid>
-              <a:tr h="457200">
+              <a:tr h="609600">
                 <a:tc>
                   <a:txBody>
                     <a:bodyPr/>
                     <a:lstStyle/>
                     <a:p>
                       <a:r>
-                        <a:t>Part</a:t>
+                        <a:t>Location</a:t>
                       </a:r>
                     </a:p>
                   </a:txBody>
@@ -3349,7 +3350,7 @@
                     <a:lstStyle/>
                     <a:p>
                       <a:r>
-                        <a:t>Supplier</a:t>
+                        <a:t>Capacity Spec</a:t>
                       </a:r>
                     </a:p>
                   </a:txBody>
@@ -3361,21 +3362,7 @@
                     <a:lstStyle/>
                     <a:p>
                       <a:r>
-                        <a:t>Lead Time</a:t>
-                      </a:r>
-                    </a:p>
-                  </a:txBody>
-                  <a:tcPr/>
-                </a:tc>
-              </a:tr>
-              <a:tr h="457200">
-                <a:tc>
-                  <a:txBody>
-                    <a:bodyPr/>
-                    <a:lstStyle/>
-                    <a:p>
-                      <a:r>
-                        <a:t>Frame</a:t>
+                        <a:t>Value</a:t>
                       </a:r>
                     </a:p>
                   </a:txBody>
@@ -3387,7 +3374,21 @@
                     <a:lstStyle/>
                     <a:p>
                       <a:r>
-                        <a:t>FrameForge Ltd</a:t>
+                        <a:t>Other Feature</a:t>
+                      </a:r>
+                    </a:p>
+                  </a:txBody>
+                  <a:tcPr/>
+                </a:tc>
+              </a:tr>
+              <a:tr h="609600">
+                <a:tc>
+                  <a:txBody>
+                    <a:bodyPr/>
+                    <a:lstStyle/>
+                    <a:p>
+                      <a:r>
+                        <a:t>North Intake Warehouse</a:t>
                       </a:r>
                     </a:p>
                   </a:txBody>
@@ -3399,21 +3400,7 @@
                     <a:lstStyle/>
                     <a:p>
                       <a:r>
-                        <a:t>14 days</a:t>
-                      </a:r>
-                    </a:p>
-                  </a:txBody>
-                  <a:tcPr/>
-                </a:tc>
-              </a:tr>
-              <a:tr h="457200">
-                <a:tc>
-                  <a:txBody>
-                    <a:bodyPr/>
-                    <a:lstStyle/>
-                    <a:p>
-                      <a:r>
-                        <a:t>Wheelset</a:t>
+                        <a:t>Warehouse Capacity</a:t>
                       </a:r>
                     </a:p>
                   </a:txBody>
@@ -3425,7 +3412,7 @@
                     <a:lstStyle/>
                     <a:p>
                       <a:r>
-                        <a:t>RollRight Co</a:t>
+                        <a:t>3000 units</a:t>
                       </a:r>
                     </a:p>
                   </a:txBody>
@@ -3437,21 +3424,21 @@
                     <a:lstStyle/>
                     <a:p>
                       <a:r>
-                        <a:t>7 days</a:t>
+                        <a:t>Goods-Receipt Log</a:t>
                       </a:r>
                     </a:p>
                   </a:txBody>
                   <a:tcPr/>
                 </a:tc>
               </a:tr>
-              <a:tr h="457200">
+              <a:tr h="609600">
                 <a:tc>
                   <a:txBody>
                     <a:bodyPr/>
                     <a:lstStyle/>
                     <a:p>
                       <a:r>
-                        <a:t>Drivetrain</a:t>
+                        <a:t>South Distribution Center</a:t>
                       </a:r>
                     </a:p>
                   </a:txBody>
@@ -3463,7 +3450,7 @@
                     <a:lstStyle/>
                     <a:p>
                       <a:r>
-                        <a:t>GearWorks Inc</a:t>
+                        <a:t>DC Capacity</a:t>
                       </a:r>
                     </a:p>
                   </a:txBody>
@@ -3475,21 +3462,7 @@
                     <a:lstStyle/>
                     <a:p>
                       <a:r>
-                        <a:t>10 days</a:t>
-                      </a:r>
-                    </a:p>
-                  </a:txBody>
-                  <a:tcPr/>
-                </a:tc>
-              </a:tr>
-              <a:tr h="457200">
-                <a:tc>
-                  <a:txBody>
-                    <a:bodyPr/>
-                    <a:lstStyle/>
-                    <a:p>
-                      <a:r>
-                        <a:t>Brake Set</a:t>
+                        <a:t>1500 units</a:t>
                       </a:r>
                     </a:p>
                   </a:txBody>
@@ -3501,57 +3474,7 @@
                     <a:lstStyle/>
                     <a:p>
                       <a:r>
-                        <a:t>BrakeSafe GmbH</a:t>
-                      </a:r>
-                    </a:p>
-                  </a:txBody>
-                  <a:tcPr/>
-                </a:tc>
-                <a:tc>
-                  <a:txBody>
-                    <a:bodyPr/>
-                    <a:lstStyle/>
-                    <a:p>
-                      <a:r>
-                        <a:t>10 days</a:t>
-                      </a:r>
-                    </a:p>
-                  </a:txBody>
-                  <a:tcPr/>
-                </a:tc>
-              </a:tr>
-              <a:tr h="457200">
-                <a:tc>
-                  <a:txBody>
-                    <a:bodyPr/>
-                    <a:lstStyle/>
-                    <a:p>
-                      <a:r>
-                        <a:t>Suspension Fork</a:t>
-                      </a:r>
-                    </a:p>
-                  </a:txBody>
-                  <a:tcPr/>
-                </a:tc>
-                <a:tc>
-                  <a:txBody>
-                    <a:bodyPr/>
-                    <a:lstStyle/>
-                    <a:p>
-                      <a:r>
-                        <a:t>ForkFactory Co</a:t>
-                      </a:r>
-                    </a:p>
-                  </a:txBody>
-                  <a:tcPr/>
-                </a:tc>
-                <a:tc>
-                  <a:txBody>
-                    <a:bodyPr/>
-                    <a:lstStyle/>
-                    <a:p>
-                      <a:r>
-                        <a:t>12 days</a:t>
+                        <a:t>Staging Area</a:t>
                       </a:r>
                     </a:p>
                   </a:txBody>

</xml_diff>